<commit_message>
Add the project report, and align the deck with it
A twelve-page A4 report covering the whole project: the problem, the boundary
with Viseca, the architecture, the seven stages, the four design decisions, the
live results, what only a real API call could tell us, the eight defects and
how each was caught, the model layer and its measurement, the team, and what is
still open.

The deck gains a slide the work had outgrown — the optional model, built and
measured and switched off — because "we put a model in and then took it out
after measuring" is a stronger answer to "where is the AI" than either
extreme. Both artefacts now carry the same figures from the same sources, and
scripts/build-docs.sh rebuilds them together so they cannot drift apart.

Wiktor's name is corrected throughout, from the spelling supplied to the one
his own commits use.

Rendered and read rather than assumed, which is how the deck's earlier
collisions were caught; this pass found none.
</commit_message>
<xml_diff>
--- a/deck/agent-on-a-leash.pptx
+++ b/deck/agent-on-a-leash.pptx
@@ -15,6 +15,7 @@
     <p:sldId id="263" r:id="rId14"/>
     <p:sldId id="264" r:id="rId15"/>
     <p:sldId id="265" r:id="rId16"/>
+    <p:sldId id="266" r:id="rId17"/>
   </p:sldIdLst>
   <p:sldSz cx="12191695" cy="6858000" type="screen4x3"/>
   <p:notesSz cx="6858000" cy="9144000"/>
@@ -3472,7 +3473,7 @@
                 </a:solidFill>
                 <a:latin typeface="IBM Plex Mono"/>
               </a:rPr>
-              <a:t>Ahmad Tabsho · Wictor Łażewski · Simon Markiewicz · Tacdin Ozmen</a:t>
+              <a:t>Ahmad Tabsho · Wiktor Łażewski · Simon Markiewicz · Tacdin Ozmen</a:t>
             </a:r>
           </a:p>
         </p:txBody>
@@ -3560,7 +3561,7 @@
                 </a:solidFill>
                 <a:latin typeface="IBM Plex Mono"/>
               </a:rPr>
-              <a:t>LIVE ON THE SANDBOX</a:t>
+              <a:t>ANSWERED ON THE LIVE API</a:t>
             </a:r>
           </a:p>
         </p:txBody>
@@ -3658,7 +3659,7 @@
         <p:spPr>
           <a:xfrm>
             <a:off x="8588959" y="3767328"/>
-            <a:ext cx="2743200" cy="548640"/>
+            <a:ext cx="2743200" cy="731520"/>
           </a:xfrm>
           <a:prstGeom prst="rect">
             <a:avLst/>
@@ -3706,6 +3707,25 @@
                 <a:latin typeface="IBM Plex Mono"/>
               </a:rPr>
               <a:t>8000 ms  allowed</a:t>
+            </a:r>
+          </a:p>
+          <a:p>
+            <a:pPr algn="l">
+              <a:lnSpc>
+                <a:spcPct val="130000"/>
+              </a:lnSpc>
+              <a:spcAft>
+                <a:spcPts val="0"/>
+              </a:spcAft>
+            </a:pPr>
+            <a:r>
+              <a:rPr sz="1150" b="0">
+                <a:solidFill>
+                  <a:srgbClr val="94A3B2"/>
+                </a:solidFill>
+                <a:latin typeface="IBM Plex Mono"/>
+              </a:rPr>
+              <a:t>    299  tests</a:t>
             </a:r>
           </a:p>
         </p:txBody>
@@ -3774,6 +3794,844 @@
       </p:sp>
       <p:sp>
         <p:nvSpPr>
+          <p:cNvPr id="3" name="TextBox 2"/>
+          <p:cNvSpPr txBox="1"/>
+          <p:nvPr/>
+        </p:nvSpPr>
+        <p:spPr>
+          <a:xfrm>
+            <a:off x="713232" y="566928"/>
+            <a:ext cx="8229600" cy="274320"/>
+          </a:xfrm>
+          <a:prstGeom prst="rect">
+            <a:avLst/>
+          </a:prstGeom>
+          <a:noFill/>
+        </p:spPr>
+        <p:txBody>
+          <a:bodyPr wrap="square" anchor="t" lIns="0" rIns="0" tIns="0" bIns="0">
+            <a:spAutoFit/>
+          </a:bodyPr>
+          <a:lstStyle/>
+          <a:p>
+            <a:pPr algn="l">
+              <a:lnSpc>
+                <a:spcPct val="118000"/>
+              </a:lnSpc>
+              <a:spcAft>
+                <a:spcPts val="0"/>
+              </a:spcAft>
+            </a:pPr>
+            <a:r>
+              <a:rPr sz="1100" b="0" spc="160">
+                <a:solidFill>
+                  <a:srgbClr val="74ABF0"/>
+                </a:solidFill>
+                <a:latin typeface="IBM Plex Mono"/>
+              </a:rPr>
+              <a:t>TEAM PRISMAI</a:t>
+            </a:r>
+          </a:p>
+        </p:txBody>
+      </p:sp>
+      <p:sp>
+        <p:nvSpPr>
+          <p:cNvPr id="4" name="TextBox 3"/>
+          <p:cNvSpPr txBox="1"/>
+          <p:nvPr/>
+        </p:nvSpPr>
+        <p:spPr>
+          <a:xfrm>
+            <a:off x="713232" y="932688"/>
+            <a:ext cx="10058400" cy="1371600"/>
+          </a:xfrm>
+          <a:prstGeom prst="rect">
+            <a:avLst/>
+          </a:prstGeom>
+          <a:noFill/>
+        </p:spPr>
+        <p:txBody>
+          <a:bodyPr wrap="square" anchor="t" lIns="0" rIns="0" tIns="0" bIns="0">
+            <a:spAutoFit/>
+          </a:bodyPr>
+          <a:lstStyle/>
+          <a:p>
+            <a:pPr algn="l">
+              <a:lnSpc>
+                <a:spcPct val="102000"/>
+              </a:lnSpc>
+              <a:spcAft>
+                <a:spcPts val="0"/>
+              </a:spcAft>
+            </a:pPr>
+            <a:r>
+              <a:rPr sz="3800" b="1">
+                <a:solidFill>
+                  <a:srgbClr val="EDF2F7"/>
+                </a:solidFill>
+                <a:latin typeface="IBM Plex Sans"/>
+              </a:rPr>
+              <a:t>Who built it</a:t>
+            </a:r>
+          </a:p>
+        </p:txBody>
+      </p:sp>
+      <p:pic>
+        <p:nvPicPr>
+          <p:cNvPr id="5" name="Picture 4" descr="ahmad.png"/>
+          <p:cNvPicPr>
+            <a:picLocks noChangeAspect="1"/>
+          </p:cNvPicPr>
+          <p:nvPr/>
+        </p:nvPicPr>
+        <p:blipFill>
+          <a:blip r:embed="rId2"/>
+          <a:stretch>
+            <a:fillRect/>
+          </a:stretch>
+        </p:blipFill>
+        <p:spPr>
+          <a:xfrm>
+            <a:off x="1229868" y="2084831"/>
+            <a:ext cx="1572768" cy="1572768"/>
+          </a:xfrm>
+          <a:prstGeom prst="rect">
+            <a:avLst/>
+          </a:prstGeom>
+        </p:spPr>
+      </p:pic>
+      <p:sp>
+        <p:nvSpPr>
+          <p:cNvPr id="6" name="TextBox 5"/>
+          <p:cNvSpPr txBox="1"/>
+          <p:nvPr/>
+        </p:nvSpPr>
+        <p:spPr>
+          <a:xfrm>
+            <a:off x="713232" y="3858768"/>
+            <a:ext cx="2606040" cy="365760"/>
+          </a:xfrm>
+          <a:prstGeom prst="rect">
+            <a:avLst/>
+          </a:prstGeom>
+          <a:noFill/>
+        </p:spPr>
+        <p:txBody>
+          <a:bodyPr wrap="square" anchor="t" lIns="0" rIns="0" tIns="0" bIns="0">
+            <a:spAutoFit/>
+          </a:bodyPr>
+          <a:lstStyle/>
+          <a:p>
+            <a:pPr algn="ctr">
+              <a:lnSpc>
+                <a:spcPct val="118000"/>
+              </a:lnSpc>
+              <a:spcAft>
+                <a:spcPts val="0"/>
+              </a:spcAft>
+            </a:pPr>
+            <a:r>
+              <a:rPr sz="1600" b="1">
+                <a:solidFill>
+                  <a:srgbClr val="EDF2F7"/>
+                </a:solidFill>
+                <a:latin typeface="IBM Plex Sans"/>
+              </a:rPr>
+              <a:t>Ahmad Tabsho</a:t>
+            </a:r>
+          </a:p>
+        </p:txBody>
+      </p:sp>
+      <p:sp>
+        <p:nvSpPr>
+          <p:cNvPr id="7" name="Rectangle 6"/>
+          <p:cNvSpPr/>
+          <p:nvPr/>
+        </p:nvSpPr>
+        <p:spPr>
+          <a:xfrm>
+            <a:off x="1696212" y="4315968"/>
+            <a:ext cx="640080" cy="20320"/>
+          </a:xfrm>
+          <a:prstGeom prst="rect">
+            <a:avLst/>
+          </a:prstGeom>
+          <a:solidFill>
+            <a:srgbClr val="74ABF0"/>
+          </a:solidFill>
+          <a:ln>
+            <a:noFill/>
+          </a:ln>
+          <a:effectLst/>
+        </p:spPr>
+        <p:style>
+          <a:lnRef idx="1">
+            <a:schemeClr val="accent1"/>
+          </a:lnRef>
+          <a:fillRef idx="3">
+            <a:schemeClr val="accent1"/>
+          </a:fillRef>
+          <a:effectRef idx="2">
+            <a:schemeClr val="accent1"/>
+          </a:effectRef>
+          <a:fontRef idx="minor">
+            <a:schemeClr val="lt1"/>
+          </a:fontRef>
+        </p:style>
+        <p:txBody>
+          <a:bodyPr rtlCol="0" anchor="ctr"/>
+          <a:lstStyle/>
+          <a:p>
+            <a:pPr algn="ctr"/>
+          </a:p>
+        </p:txBody>
+      </p:sp>
+      <p:sp>
+        <p:nvSpPr>
+          <p:cNvPr id="8" name="TextBox 7"/>
+          <p:cNvSpPr txBox="1"/>
+          <p:nvPr/>
+        </p:nvSpPr>
+        <p:spPr>
+          <a:xfrm>
+            <a:off x="713232" y="4517136"/>
+            <a:ext cx="2606040" cy="1554480"/>
+          </a:xfrm>
+          <a:prstGeom prst="rect">
+            <a:avLst/>
+          </a:prstGeom>
+          <a:noFill/>
+        </p:spPr>
+        <p:txBody>
+          <a:bodyPr wrap="square" anchor="t" lIns="0" rIns="0" tIns="0" bIns="0">
+            <a:spAutoFit/>
+          </a:bodyPr>
+          <a:lstStyle/>
+          <a:p>
+            <a:pPr algn="ctr">
+              <a:lnSpc>
+                <a:spcPct val="134000"/>
+              </a:lnSpc>
+              <a:spcAft>
+                <a:spcPts val="0"/>
+              </a:spcAft>
+            </a:pPr>
+            <a:r>
+              <a:rPr sz="1150" b="0">
+                <a:solidFill>
+                  <a:srgbClr val="94A3B2"/>
+                </a:solidFill>
+                <a:latin typeface="IBM Plex Sans"/>
+              </a:rPr>
+              <a:t>Natural-language policy compiler, prompt-injection defence filters, and the lightweight LLM advisory layer with hard timeouts and fallback logic.</a:t>
+            </a:r>
+          </a:p>
+        </p:txBody>
+      </p:sp>
+      <p:pic>
+        <p:nvPicPr>
+          <p:cNvPr id="9" name="Picture 8" descr="wictor.png"/>
+          <p:cNvPicPr>
+            <a:picLocks noChangeAspect="1"/>
+          </p:cNvPicPr>
+          <p:nvPr/>
+        </p:nvPicPr>
+        <p:blipFill>
+          <a:blip r:embed="rId3"/>
+          <a:stretch>
+            <a:fillRect/>
+          </a:stretch>
+        </p:blipFill>
+        <p:spPr>
+          <a:xfrm>
+            <a:off x="4055364" y="2084831"/>
+            <a:ext cx="1572768" cy="1572768"/>
+          </a:xfrm>
+          <a:prstGeom prst="rect">
+            <a:avLst/>
+          </a:prstGeom>
+        </p:spPr>
+      </p:pic>
+      <p:sp>
+        <p:nvSpPr>
+          <p:cNvPr id="10" name="TextBox 9"/>
+          <p:cNvSpPr txBox="1"/>
+          <p:nvPr/>
+        </p:nvSpPr>
+        <p:spPr>
+          <a:xfrm>
+            <a:off x="3538728" y="3858768"/>
+            <a:ext cx="2606040" cy="365760"/>
+          </a:xfrm>
+          <a:prstGeom prst="rect">
+            <a:avLst/>
+          </a:prstGeom>
+          <a:noFill/>
+        </p:spPr>
+        <p:txBody>
+          <a:bodyPr wrap="square" anchor="t" lIns="0" rIns="0" tIns="0" bIns="0">
+            <a:spAutoFit/>
+          </a:bodyPr>
+          <a:lstStyle/>
+          <a:p>
+            <a:pPr algn="ctr">
+              <a:lnSpc>
+                <a:spcPct val="118000"/>
+              </a:lnSpc>
+              <a:spcAft>
+                <a:spcPts val="0"/>
+              </a:spcAft>
+            </a:pPr>
+            <a:r>
+              <a:rPr sz="1600" b="1">
+                <a:solidFill>
+                  <a:srgbClr val="EDF2F7"/>
+                </a:solidFill>
+                <a:latin typeface="IBM Plex Sans"/>
+              </a:rPr>
+              <a:t>Wiktor Łażewski</a:t>
+            </a:r>
+          </a:p>
+        </p:txBody>
+      </p:sp>
+      <p:sp>
+        <p:nvSpPr>
+          <p:cNvPr id="11" name="Rectangle 10"/>
+          <p:cNvSpPr/>
+          <p:nvPr/>
+        </p:nvSpPr>
+        <p:spPr>
+          <a:xfrm>
+            <a:off x="4521708" y="4315968"/>
+            <a:ext cx="640080" cy="20320"/>
+          </a:xfrm>
+          <a:prstGeom prst="rect">
+            <a:avLst/>
+          </a:prstGeom>
+          <a:solidFill>
+            <a:srgbClr val="74ABF0"/>
+          </a:solidFill>
+          <a:ln>
+            <a:noFill/>
+          </a:ln>
+          <a:effectLst/>
+        </p:spPr>
+        <p:style>
+          <a:lnRef idx="1">
+            <a:schemeClr val="accent1"/>
+          </a:lnRef>
+          <a:fillRef idx="3">
+            <a:schemeClr val="accent1"/>
+          </a:fillRef>
+          <a:effectRef idx="2">
+            <a:schemeClr val="accent1"/>
+          </a:effectRef>
+          <a:fontRef idx="minor">
+            <a:schemeClr val="lt1"/>
+          </a:fontRef>
+        </p:style>
+        <p:txBody>
+          <a:bodyPr rtlCol="0" anchor="ctr"/>
+          <a:lstStyle/>
+          <a:p>
+            <a:pPr algn="ctr"/>
+          </a:p>
+        </p:txBody>
+      </p:sp>
+      <p:sp>
+        <p:nvSpPr>
+          <p:cNvPr id="12" name="TextBox 11"/>
+          <p:cNvSpPr txBox="1"/>
+          <p:nvPr/>
+        </p:nvSpPr>
+        <p:spPr>
+          <a:xfrm>
+            <a:off x="3538728" y="4517136"/>
+            <a:ext cx="2606040" cy="1554480"/>
+          </a:xfrm>
+          <a:prstGeom prst="rect">
+            <a:avLst/>
+          </a:prstGeom>
+          <a:noFill/>
+        </p:spPr>
+        <p:txBody>
+          <a:bodyPr wrap="square" anchor="t" lIns="0" rIns="0" tIns="0" bIns="0">
+            <a:spAutoFit/>
+          </a:bodyPr>
+          <a:lstStyle/>
+          <a:p>
+            <a:pPr algn="ctr">
+              <a:lnSpc>
+                <a:spcPct val="134000"/>
+              </a:lnSpc>
+              <a:spcAft>
+                <a:spcPts val="0"/>
+              </a:spcAft>
+            </a:pPr>
+            <a:r>
+              <a:rPr sz="1150" b="0">
+                <a:solidFill>
+                  <a:srgbClr val="94A3B2"/>
+                </a:solidFill>
+                <a:latin typeface="IBM Plex Sans"/>
+              </a:rPr>
+              <a:t>Offline replay harness over the synthetic datasets, the live sandbox API client, and latency benchmarking to stay well under platform thresholds.</a:t>
+            </a:r>
+          </a:p>
+        </p:txBody>
+      </p:sp>
+      <p:pic>
+        <p:nvPicPr>
+          <p:cNvPr id="13" name="Picture 12" descr="simon.png"/>
+          <p:cNvPicPr>
+            <a:picLocks noChangeAspect="1"/>
+          </p:cNvPicPr>
+          <p:nvPr/>
+        </p:nvPicPr>
+        <p:blipFill>
+          <a:blip r:embed="rId4"/>
+          <a:stretch>
+            <a:fillRect/>
+          </a:stretch>
+        </p:blipFill>
+        <p:spPr>
+          <a:xfrm>
+            <a:off x="6880860" y="2084831"/>
+            <a:ext cx="1572768" cy="1572768"/>
+          </a:xfrm>
+          <a:prstGeom prst="rect">
+            <a:avLst/>
+          </a:prstGeom>
+        </p:spPr>
+      </p:pic>
+      <p:sp>
+        <p:nvSpPr>
+          <p:cNvPr id="14" name="TextBox 13"/>
+          <p:cNvSpPr txBox="1"/>
+          <p:nvPr/>
+        </p:nvSpPr>
+        <p:spPr>
+          <a:xfrm>
+            <a:off x="6364224" y="3858768"/>
+            <a:ext cx="2606040" cy="365760"/>
+          </a:xfrm>
+          <a:prstGeom prst="rect">
+            <a:avLst/>
+          </a:prstGeom>
+          <a:noFill/>
+        </p:spPr>
+        <p:txBody>
+          <a:bodyPr wrap="square" anchor="t" lIns="0" rIns="0" tIns="0" bIns="0">
+            <a:spAutoFit/>
+          </a:bodyPr>
+          <a:lstStyle/>
+          <a:p>
+            <a:pPr algn="ctr">
+              <a:lnSpc>
+                <a:spcPct val="118000"/>
+              </a:lnSpc>
+              <a:spcAft>
+                <a:spcPts val="0"/>
+              </a:spcAft>
+            </a:pPr>
+            <a:r>
+              <a:rPr sz="1600" b="1">
+                <a:solidFill>
+                  <a:srgbClr val="EDF2F7"/>
+                </a:solidFill>
+                <a:latin typeface="IBM Plex Sans"/>
+              </a:rPr>
+              <a:t>Simon Markiewicz</a:t>
+            </a:r>
+          </a:p>
+        </p:txBody>
+      </p:sp>
+      <p:sp>
+        <p:nvSpPr>
+          <p:cNvPr id="15" name="Rectangle 14"/>
+          <p:cNvSpPr/>
+          <p:nvPr/>
+        </p:nvSpPr>
+        <p:spPr>
+          <a:xfrm>
+            <a:off x="7347204" y="4315968"/>
+            <a:ext cx="640080" cy="20320"/>
+          </a:xfrm>
+          <a:prstGeom prst="rect">
+            <a:avLst/>
+          </a:prstGeom>
+          <a:solidFill>
+            <a:srgbClr val="74ABF0"/>
+          </a:solidFill>
+          <a:ln>
+            <a:noFill/>
+          </a:ln>
+          <a:effectLst/>
+        </p:spPr>
+        <p:style>
+          <a:lnRef idx="1">
+            <a:schemeClr val="accent1"/>
+          </a:lnRef>
+          <a:fillRef idx="3">
+            <a:schemeClr val="accent1"/>
+          </a:fillRef>
+          <a:effectRef idx="2">
+            <a:schemeClr val="accent1"/>
+          </a:effectRef>
+          <a:fontRef idx="minor">
+            <a:schemeClr val="lt1"/>
+          </a:fontRef>
+        </p:style>
+        <p:txBody>
+          <a:bodyPr rtlCol="0" anchor="ctr"/>
+          <a:lstStyle/>
+          <a:p>
+            <a:pPr algn="ctr"/>
+          </a:p>
+        </p:txBody>
+      </p:sp>
+      <p:sp>
+        <p:nvSpPr>
+          <p:cNvPr id="16" name="TextBox 15"/>
+          <p:cNvSpPr txBox="1"/>
+          <p:nvPr/>
+        </p:nvSpPr>
+        <p:spPr>
+          <a:xfrm>
+            <a:off x="6364224" y="4517136"/>
+            <a:ext cx="2606040" cy="1554480"/>
+          </a:xfrm>
+          <a:prstGeom prst="rect">
+            <a:avLst/>
+          </a:prstGeom>
+          <a:noFill/>
+        </p:spPr>
+        <p:txBody>
+          <a:bodyPr wrap="square" anchor="t" lIns="0" rIns="0" tIns="0" bIns="0">
+            <a:spAutoFit/>
+          </a:bodyPr>
+          <a:lstStyle/>
+          <a:p>
+            <a:pPr algn="ctr">
+              <a:lnSpc>
+                <a:spcPct val="134000"/>
+              </a:lnSpc>
+              <a:spcAft>
+                <a:spcPts val="0"/>
+              </a:spcAft>
+            </a:pPr>
+            <a:r>
+              <a:rPr sz="1150" b="0">
+                <a:solidFill>
+                  <a:srgbClr val="94A3B2"/>
+                </a:solidFill>
+                <a:latin typeface="IBM Plex Sans"/>
+              </a:rPr>
+              <a:t>Spend mandate policies and merchant trust validation, partner alignment with mentors, and the presentation flow across the core demo scenarios.</a:t>
+            </a:r>
+          </a:p>
+        </p:txBody>
+      </p:sp>
+      <p:pic>
+        <p:nvPicPr>
+          <p:cNvPr id="17" name="Picture 16" descr="tacdin.png"/>
+          <p:cNvPicPr>
+            <a:picLocks noChangeAspect="1"/>
+          </p:cNvPicPr>
+          <p:nvPr/>
+        </p:nvPicPr>
+        <p:blipFill>
+          <a:blip r:embed="rId5"/>
+          <a:stretch>
+            <a:fillRect/>
+          </a:stretch>
+        </p:blipFill>
+        <p:spPr>
+          <a:xfrm>
+            <a:off x="9706356" y="2084831"/>
+            <a:ext cx="1572768" cy="1572768"/>
+          </a:xfrm>
+          <a:prstGeom prst="rect">
+            <a:avLst/>
+          </a:prstGeom>
+        </p:spPr>
+      </p:pic>
+      <p:sp>
+        <p:nvSpPr>
+          <p:cNvPr id="18" name="TextBox 17"/>
+          <p:cNvSpPr txBox="1"/>
+          <p:nvPr/>
+        </p:nvSpPr>
+        <p:spPr>
+          <a:xfrm>
+            <a:off x="9189720" y="3858768"/>
+            <a:ext cx="2606040" cy="365760"/>
+          </a:xfrm>
+          <a:prstGeom prst="rect">
+            <a:avLst/>
+          </a:prstGeom>
+          <a:noFill/>
+        </p:spPr>
+        <p:txBody>
+          <a:bodyPr wrap="square" anchor="t" lIns="0" rIns="0" tIns="0" bIns="0">
+            <a:spAutoFit/>
+          </a:bodyPr>
+          <a:lstStyle/>
+          <a:p>
+            <a:pPr algn="ctr">
+              <a:lnSpc>
+                <a:spcPct val="118000"/>
+              </a:lnSpc>
+              <a:spcAft>
+                <a:spcPts val="0"/>
+              </a:spcAft>
+            </a:pPr>
+            <a:r>
+              <a:rPr sz="1600" b="1">
+                <a:solidFill>
+                  <a:srgbClr val="EDF2F7"/>
+                </a:solidFill>
+                <a:latin typeface="IBM Plex Sans"/>
+              </a:rPr>
+              <a:t>Tacdin Ozmen</a:t>
+            </a:r>
+          </a:p>
+        </p:txBody>
+      </p:sp>
+      <p:sp>
+        <p:nvSpPr>
+          <p:cNvPr id="19" name="Rectangle 18"/>
+          <p:cNvSpPr/>
+          <p:nvPr/>
+        </p:nvSpPr>
+        <p:spPr>
+          <a:xfrm>
+            <a:off x="10172700" y="4315968"/>
+            <a:ext cx="640080" cy="20320"/>
+          </a:xfrm>
+          <a:prstGeom prst="rect">
+            <a:avLst/>
+          </a:prstGeom>
+          <a:solidFill>
+            <a:srgbClr val="74ABF0"/>
+          </a:solidFill>
+          <a:ln>
+            <a:noFill/>
+          </a:ln>
+          <a:effectLst/>
+        </p:spPr>
+        <p:style>
+          <a:lnRef idx="1">
+            <a:schemeClr val="accent1"/>
+          </a:lnRef>
+          <a:fillRef idx="3">
+            <a:schemeClr val="accent1"/>
+          </a:fillRef>
+          <a:effectRef idx="2">
+            <a:schemeClr val="accent1"/>
+          </a:effectRef>
+          <a:fontRef idx="minor">
+            <a:schemeClr val="lt1"/>
+          </a:fontRef>
+        </p:style>
+        <p:txBody>
+          <a:bodyPr rtlCol="0" anchor="ctr"/>
+          <a:lstStyle/>
+          <a:p>
+            <a:pPr algn="ctr"/>
+          </a:p>
+        </p:txBody>
+      </p:sp>
+      <p:sp>
+        <p:nvSpPr>
+          <p:cNvPr id="20" name="TextBox 19"/>
+          <p:cNvSpPr txBox="1"/>
+          <p:nvPr/>
+        </p:nvSpPr>
+        <p:spPr>
+          <a:xfrm>
+            <a:off x="9189720" y="4517136"/>
+            <a:ext cx="2606040" cy="1554480"/>
+          </a:xfrm>
+          <a:prstGeom prst="rect">
+            <a:avLst/>
+          </a:prstGeom>
+          <a:noFill/>
+        </p:spPr>
+        <p:txBody>
+          <a:bodyPr wrap="square" anchor="t" lIns="0" rIns="0" tIns="0" bIns="0">
+            <a:spAutoFit/>
+          </a:bodyPr>
+          <a:lstStyle/>
+          <a:p>
+            <a:pPr algn="ctr">
+              <a:lnSpc>
+                <a:spcPct val="134000"/>
+              </a:lnSpc>
+              <a:spcAft>
+                <a:spcPts val="0"/>
+              </a:spcAft>
+            </a:pPr>
+            <a:r>
+              <a:rPr sz="1150" b="0">
+                <a:solidFill>
+                  <a:srgbClr val="94A3B2"/>
+                </a:solidFill>
+                <a:latin typeface="IBM Plex Sans"/>
+              </a:rPr>
+              <a:t>The core deterministic decision engine, evidence logs for approve, decline and step-up outcomes, and the link to the decoupled user interface.</a:t>
+            </a:r>
+          </a:p>
+        </p:txBody>
+      </p:sp>
+      <p:sp>
+        <p:nvSpPr>
+          <p:cNvPr id="21" name="TextBox 20"/>
+          <p:cNvSpPr txBox="1"/>
+          <p:nvPr/>
+        </p:nvSpPr>
+        <p:spPr>
+          <a:xfrm>
+            <a:off x="713232" y="6291072"/>
+            <a:ext cx="3657600" cy="256032"/>
+          </a:xfrm>
+          <a:prstGeom prst="rect">
+            <a:avLst/>
+          </a:prstGeom>
+          <a:noFill/>
+        </p:spPr>
+        <p:txBody>
+          <a:bodyPr wrap="square" anchor="t" lIns="0" rIns="0" tIns="0" bIns="0">
+            <a:spAutoFit/>
+          </a:bodyPr>
+          <a:lstStyle/>
+          <a:p>
+            <a:pPr algn="l">
+              <a:lnSpc>
+                <a:spcPct val="118000"/>
+              </a:lnSpc>
+              <a:spcAft>
+                <a:spcPts val="0"/>
+              </a:spcAft>
+            </a:pPr>
+            <a:r>
+              <a:rPr sz="950" b="0">
+                <a:solidFill>
+                  <a:srgbClr val="637280"/>
+                </a:solidFill>
+                <a:latin typeface="IBM Plex Mono"/>
+              </a:rPr>
+              <a:t>Agent on a Leash</a:t>
+            </a:r>
+          </a:p>
+        </p:txBody>
+      </p:sp>
+      <p:sp>
+        <p:nvSpPr>
+          <p:cNvPr id="22" name="TextBox 21"/>
+          <p:cNvSpPr txBox="1"/>
+          <p:nvPr/>
+        </p:nvSpPr>
+        <p:spPr>
+          <a:xfrm>
+            <a:off x="7820863" y="6291072"/>
+            <a:ext cx="3657600" cy="256032"/>
+          </a:xfrm>
+          <a:prstGeom prst="rect">
+            <a:avLst/>
+          </a:prstGeom>
+          <a:noFill/>
+        </p:spPr>
+        <p:txBody>
+          <a:bodyPr wrap="square" anchor="t" lIns="0" rIns="0" tIns="0" bIns="0">
+            <a:spAutoFit/>
+          </a:bodyPr>
+          <a:lstStyle/>
+          <a:p>
+            <a:pPr algn="r">
+              <a:lnSpc>
+                <a:spcPct val="118000"/>
+              </a:lnSpc>
+              <a:spcAft>
+                <a:spcPts val="0"/>
+              </a:spcAft>
+            </a:pPr>
+            <a:r>
+              <a:rPr sz="950" b="0">
+                <a:solidFill>
+                  <a:srgbClr val="637280"/>
+                </a:solidFill>
+                <a:latin typeface="IBM Plex Mono"/>
+              </a:rPr>
+              <a:t>10</a:t>
+            </a:r>
+          </a:p>
+        </p:txBody>
+      </p:sp>
+    </p:spTree>
+  </p:cSld>
+  <p:clrMapOvr>
+    <a:masterClrMapping/>
+  </p:clrMapOvr>
+</p:sld>
+</file>
+
+<file path=ppt/slides/slide11.xml><?xml version="1.0" encoding="utf-8"?>
+<p:sld xmlns:a="http://schemas.openxmlformats.org/drawingml/2006/main" xmlns:p="http://schemas.openxmlformats.org/presentationml/2006/main" xmlns:r="http://schemas.openxmlformats.org/officeDocument/2006/relationships">
+  <p:cSld>
+    <p:spTree>
+      <p:nvGrpSpPr>
+        <p:cNvPr id="1" name=""/>
+        <p:cNvGrpSpPr/>
+        <p:nvPr/>
+      </p:nvGrpSpPr>
+      <p:grpSpPr/>
+      <p:sp>
+        <p:nvSpPr>
+          <p:cNvPr id="2" name="Rectangle 1"/>
+          <p:cNvSpPr/>
+          <p:nvPr/>
+        </p:nvSpPr>
+        <p:spPr>
+          <a:xfrm>
+            <a:off x="0" y="0"/>
+            <a:ext cx="12191695" cy="6858000"/>
+          </a:xfrm>
+          <a:prstGeom prst="rect">
+            <a:avLst/>
+          </a:prstGeom>
+          <a:solidFill>
+            <a:srgbClr val="0B0F13"/>
+          </a:solidFill>
+          <a:ln>
+            <a:noFill/>
+          </a:ln>
+          <a:effectLst/>
+        </p:spPr>
+        <p:style>
+          <a:lnRef idx="1">
+            <a:schemeClr val="accent1"/>
+          </a:lnRef>
+          <a:fillRef idx="3">
+            <a:schemeClr val="accent1"/>
+          </a:fillRef>
+          <a:effectRef idx="2">
+            <a:schemeClr val="accent1"/>
+          </a:effectRef>
+          <a:fontRef idx="minor">
+            <a:schemeClr val="lt1"/>
+          </a:fontRef>
+        </p:style>
+        <p:txBody>
+          <a:bodyPr rtlCol="0" anchor="ctr"/>
+          <a:lstStyle/>
+          <a:p>
+            <a:pPr algn="ctr"/>
+          </a:p>
+        </p:txBody>
+      </p:sp>
+      <p:sp>
+        <p:nvSpPr>
           <p:cNvPr id="3" name="Rectangle 2"/>
           <p:cNvSpPr/>
           <p:nvPr/>
@@ -11194,7 +12052,7 @@
                 </a:solidFill>
                 <a:latin typeface="IBM Plex Sans"/>
               </a:rPr>
-              <a:t>259</a:t>
+              <a:t>299</a:t>
             </a:r>
           </a:p>
         </p:txBody>
@@ -12208,7 +13066,7 @@
                 </a:solidFill>
                 <a:latin typeface="IBM Plex Mono"/>
               </a:rPr>
-              <a:t>TEAM PRISMAI</a:t>
+              <a:t>THE OPTIONAL MODEL</a:t>
             </a:r>
           </a:p>
         </p:txBody>
@@ -12244,102 +13102,80 @@
               </a:spcAft>
             </a:pPr>
             <a:r>
-              <a:rPr sz="3800" b="1">
+              <a:rPr sz="4000" b="1">
                 <a:solidFill>
                   <a:srgbClr val="EDF2F7"/>
                 </a:solidFill>
                 <a:latin typeface="IBM Plex Sans"/>
               </a:rPr>
-              <a:t>Who built it</a:t>
-            </a:r>
-          </a:p>
-        </p:txBody>
-      </p:sp>
-      <p:pic>
-        <p:nvPicPr>
-          <p:cNvPr id="5" name="Picture 4" descr="ahmad.png"/>
-          <p:cNvPicPr>
-            <a:picLocks noChangeAspect="1"/>
-          </p:cNvPicPr>
-          <p:nvPr/>
-        </p:nvPicPr>
-        <p:blipFill>
-          <a:blip r:embed="rId2"/>
-          <a:stretch>
-            <a:fillRect/>
-          </a:stretch>
-        </p:blipFill>
-        <p:spPr>
-          <a:xfrm>
-            <a:off x="1229868" y="2084831"/>
-            <a:ext cx="1572768" cy="1572768"/>
-          </a:xfrm>
-          <a:prstGeom prst="rect">
-            <a:avLst/>
-          </a:prstGeom>
-        </p:spPr>
-      </p:pic>
-      <p:sp>
-        <p:nvSpPr>
-          <p:cNvPr id="6" name="TextBox 5"/>
-          <p:cNvSpPr txBox="1"/>
-          <p:nvPr/>
-        </p:nvSpPr>
-        <p:spPr>
-          <a:xfrm>
-            <a:off x="713232" y="3858768"/>
-            <a:ext cx="2606040" cy="365760"/>
-          </a:xfrm>
-          <a:prstGeom prst="rect">
-            <a:avLst/>
-          </a:prstGeom>
-          <a:noFill/>
-        </p:spPr>
-        <p:txBody>
-          <a:bodyPr wrap="square" anchor="t" lIns="0" rIns="0" tIns="0" bIns="0">
-            <a:spAutoFit/>
-          </a:bodyPr>
-          <a:lstStyle/>
-          <a:p>
-            <a:pPr algn="ctr">
-              <a:lnSpc>
-                <a:spcPct val="118000"/>
-              </a:lnSpc>
-              <a:spcAft>
-                <a:spcPts val="0"/>
-              </a:spcAft>
-            </a:pPr>
-            <a:r>
-              <a:rPr sz="1600" b="1">
-                <a:solidFill>
-                  <a:srgbClr val="EDF2F7"/>
+              <a:t>We built the hook, then measured it</a:t>
+            </a:r>
+          </a:p>
+        </p:txBody>
+      </p:sp>
+      <p:sp>
+        <p:nvSpPr>
+          <p:cNvPr id="5" name="TextBox 4"/>
+          <p:cNvSpPr txBox="1"/>
+          <p:nvPr/>
+        </p:nvSpPr>
+        <p:spPr>
+          <a:xfrm>
+            <a:off x="713232" y="1847088"/>
+            <a:ext cx="9692640" cy="1005840"/>
+          </a:xfrm>
+          <a:prstGeom prst="rect">
+            <a:avLst/>
+          </a:prstGeom>
+          <a:noFill/>
+        </p:spPr>
+        <p:txBody>
+          <a:bodyPr wrap="square" anchor="t" lIns="0" rIns="0" tIns="0" bIns="0">
+            <a:spAutoFit/>
+          </a:bodyPr>
+          <a:lstStyle/>
+          <a:p>
+            <a:pPr algn="l">
+              <a:lnSpc>
+                <a:spcPct val="132000"/>
+              </a:lnSpc>
+              <a:spcAft>
+                <a:spcPts val="0"/>
+              </a:spcAft>
+            </a:pPr>
+            <a:r>
+              <a:rPr sz="1700" b="0">
+                <a:solidFill>
+                  <a:srgbClr val="94A3B2"/>
                 </a:solidFill>
                 <a:latin typeface="IBM Plex Sans"/>
               </a:rPr>
-              <a:t>Ahmad Tabsho</a:t>
-            </a:r>
-          </a:p>
-        </p:txBody>
-      </p:sp>
-      <p:sp>
-        <p:nvSpPr>
-          <p:cNvPr id="7" name="Rectangle 6"/>
+              <a:t>The brief permits language models in the decision path and requires the system to stay predictable when they fail. So we made it switchable, and checked whether it earns its place.</a:t>
+            </a:r>
+          </a:p>
+        </p:txBody>
+      </p:sp>
+      <p:sp>
+        <p:nvSpPr>
+          <p:cNvPr id="6" name="Rectangle 5"/>
           <p:cNvSpPr/>
           <p:nvPr/>
         </p:nvSpPr>
         <p:spPr>
           <a:xfrm>
-            <a:off x="1696212" y="4315968"/>
-            <a:ext cx="640080" cy="20320"/>
+            <a:off x="713232" y="2798064"/>
+            <a:ext cx="6035040" cy="2377440"/>
           </a:xfrm>
           <a:prstGeom prst="rect">
             <a:avLst/>
           </a:prstGeom>
           <a:solidFill>
-            <a:srgbClr val="74ABF0"/>
+            <a:srgbClr val="151D25"/>
           </a:solidFill>
-          <a:ln>
-            <a:noFill/>
+          <a:ln w="9525">
+            <a:solidFill>
+              <a:srgbClr val="2A3642"/>
+            </a:solidFill>
           </a:ln>
           <a:effectLst/>
         </p:spPr>
@@ -12367,70 +13203,130 @@
       </p:sp>
       <p:sp>
         <p:nvSpPr>
+          <p:cNvPr id="7" name="TextBox 6"/>
+          <p:cNvSpPr txBox="1"/>
+          <p:nvPr/>
+        </p:nvSpPr>
+        <p:spPr>
+          <a:xfrm>
+            <a:off x="1005840" y="3017520"/>
+            <a:ext cx="4937760" cy="274320"/>
+          </a:xfrm>
+          <a:prstGeom prst="rect">
+            <a:avLst/>
+          </a:prstGeom>
+          <a:noFill/>
+        </p:spPr>
+        <p:txBody>
+          <a:bodyPr wrap="square" anchor="t" lIns="0" rIns="0" tIns="0" bIns="0">
+            <a:spAutoFit/>
+          </a:bodyPr>
+          <a:lstStyle/>
+          <a:p>
+            <a:pPr algn="l">
+              <a:lnSpc>
+                <a:spcPct val="118000"/>
+              </a:lnSpc>
+              <a:spcAft>
+                <a:spcPts val="0"/>
+              </a:spcAft>
+            </a:pPr>
+            <a:r>
+              <a:rPr sz="950" b="0" spc="120">
+                <a:solidFill>
+                  <a:srgbClr val="74ABF0"/>
+                </a:solidFill>
+                <a:latin typeface="IBM Plex Mono"/>
+              </a:rPr>
+              <a:t>MEASURED ON OPENROUTER, GPT-4O-MINI</a:t>
+            </a:r>
+          </a:p>
+        </p:txBody>
+      </p:sp>
+      <p:sp>
+        <p:nvSpPr>
           <p:cNvPr id="8" name="TextBox 7"/>
           <p:cNvSpPr txBox="1"/>
           <p:nvPr/>
         </p:nvSpPr>
         <p:spPr>
           <a:xfrm>
-            <a:off x="713232" y="4517136"/>
-            <a:ext cx="2606040" cy="1554480"/>
-          </a:xfrm>
-          <a:prstGeom prst="rect">
-            <a:avLst/>
-          </a:prstGeom>
-          <a:noFill/>
-        </p:spPr>
-        <p:txBody>
-          <a:bodyPr wrap="square" anchor="t" lIns="0" rIns="0" tIns="0" bIns="0">
-            <a:spAutoFit/>
-          </a:bodyPr>
-          <a:lstStyle/>
-          <a:p>
-            <a:pPr algn="ctr">
-              <a:lnSpc>
-                <a:spcPct val="134000"/>
-              </a:lnSpc>
-              <a:spcAft>
-                <a:spcPts val="0"/>
-              </a:spcAft>
-            </a:pPr>
-            <a:r>
-              <a:rPr sz="1150" b="0">
+            <a:off x="1005840" y="3401568"/>
+            <a:ext cx="3657600" cy="292608"/>
+          </a:xfrm>
+          <a:prstGeom prst="rect">
+            <a:avLst/>
+          </a:prstGeom>
+          <a:noFill/>
+        </p:spPr>
+        <p:txBody>
+          <a:bodyPr wrap="square" anchor="t" lIns="0" rIns="0" tIns="0" bIns="0">
+            <a:spAutoFit/>
+          </a:bodyPr>
+          <a:lstStyle/>
+          <a:p>
+            <a:pPr algn="l">
+              <a:lnSpc>
+                <a:spcPct val="118000"/>
+              </a:lnSpc>
+              <a:spcAft>
+                <a:spcPts val="0"/>
+              </a:spcAft>
+            </a:pPr>
+            <a:r>
+              <a:rPr sz="1350" b="0">
                 <a:solidFill>
                   <a:srgbClr val="94A3B2"/>
                 </a:solidFill>
                 <a:latin typeface="IBM Plex Sans"/>
               </a:rPr>
-              <a:t>Natural-language policy compiler, prompt-injection defence filters, and the lightweight LLM advisory layer with hard timeouts and fallback logic.</a:t>
-            </a:r>
-          </a:p>
-        </p:txBody>
-      </p:sp>
-      <p:pic>
-        <p:nvPicPr>
-          <p:cNvPr id="9" name="Picture 8" descr="wictor.png"/>
-          <p:cNvPicPr>
-            <a:picLocks noChangeAspect="1"/>
-          </p:cNvPicPr>
-          <p:nvPr/>
-        </p:nvPicPr>
-        <p:blipFill>
-          <a:blip r:embed="rId3"/>
-          <a:stretch>
-            <a:fillRect/>
-          </a:stretch>
-        </p:blipFill>
-        <p:spPr>
-          <a:xfrm>
-            <a:off x="4055364" y="2084831"/>
-            <a:ext cx="1572768" cy="1572768"/>
-          </a:xfrm>
-          <a:prstGeom prst="rect">
-            <a:avLst/>
-          </a:prstGeom>
-        </p:spPr>
-      </p:pic>
+              <a:t>Slowest decision, model off</a:t>
+            </a:r>
+          </a:p>
+        </p:txBody>
+      </p:sp>
+      <p:sp>
+        <p:nvSpPr>
+          <p:cNvPr id="9" name="TextBox 8"/>
+          <p:cNvSpPr txBox="1"/>
+          <p:nvPr/>
+        </p:nvSpPr>
+        <p:spPr>
+          <a:xfrm>
+            <a:off x="4828032" y="3401568"/>
+            <a:ext cx="1645920" cy="292608"/>
+          </a:xfrm>
+          <a:prstGeom prst="rect">
+            <a:avLst/>
+          </a:prstGeom>
+          <a:noFill/>
+        </p:spPr>
+        <p:txBody>
+          <a:bodyPr wrap="square" anchor="t" lIns="0" rIns="0" tIns="0" bIns="0">
+            <a:spAutoFit/>
+          </a:bodyPr>
+          <a:lstStyle/>
+          <a:p>
+            <a:pPr algn="r">
+              <a:lnSpc>
+                <a:spcPct val="118000"/>
+              </a:lnSpc>
+              <a:spcAft>
+                <a:spcPts val="0"/>
+              </a:spcAft>
+            </a:pPr>
+            <a:r>
+              <a:rPr sz="1400" b="1">
+                <a:solidFill>
+                  <a:srgbClr val="4FC08D"/>
+                </a:solidFill>
+                <a:latin typeface="IBM Plex Mono"/>
+              </a:rPr>
+              <a:t>0.97 ms</a:t>
+            </a:r>
+          </a:p>
+        </p:txBody>
+      </p:sp>
       <p:sp>
         <p:nvSpPr>
           <p:cNvPr id="10" name="TextBox 9"/>
@@ -12439,21 +13335,21 @@
         </p:nvSpPr>
         <p:spPr>
           <a:xfrm>
-            <a:off x="3538728" y="3858768"/>
-            <a:ext cx="2606040" cy="365760"/>
-          </a:xfrm>
-          <a:prstGeom prst="rect">
-            <a:avLst/>
-          </a:prstGeom>
-          <a:noFill/>
-        </p:spPr>
-        <p:txBody>
-          <a:bodyPr wrap="square" anchor="t" lIns="0" rIns="0" tIns="0" bIns="0">
-            <a:spAutoFit/>
-          </a:bodyPr>
-          <a:lstStyle/>
-          <a:p>
-            <a:pPr algn="ctr">
+            <a:off x="1005840" y="3831336"/>
+            <a:ext cx="3657600" cy="292608"/>
+          </a:xfrm>
+          <a:prstGeom prst="rect">
+            <a:avLst/>
+          </a:prstGeom>
+          <a:noFill/>
+        </p:spPr>
+        <p:txBody>
+          <a:bodyPr wrap="square" anchor="t" lIns="0" rIns="0" tIns="0" bIns="0">
+            <a:spAutoFit/>
+          </a:bodyPr>
+          <a:lstStyle/>
+          <a:p>
+            <a:pPr algn="l">
               <a:lnSpc>
                 <a:spcPct val="118000"/>
               </a:lnSpc>
@@ -12462,36 +13358,248 @@
               </a:spcAft>
             </a:pPr>
             <a:r>
-              <a:rPr sz="1600" b="1">
-                <a:solidFill>
-                  <a:srgbClr val="EDF2F7"/>
+              <a:rPr sz="1350" b="0">
+                <a:solidFill>
+                  <a:srgbClr val="94A3B2"/>
                 </a:solidFill>
                 <a:latin typeface="IBM Plex Sans"/>
               </a:rPr>
-              <a:t>Wictor Łażewski</a:t>
-            </a:r>
-          </a:p>
-        </p:txBody>
-      </p:sp>
-      <p:sp>
-        <p:nvSpPr>
-          <p:cNvPr id="11" name="Rectangle 10"/>
+              <a:t>Slowest decision, model on</a:t>
+            </a:r>
+          </a:p>
+        </p:txBody>
+      </p:sp>
+      <p:sp>
+        <p:nvSpPr>
+          <p:cNvPr id="11" name="TextBox 10"/>
+          <p:cNvSpPr txBox="1"/>
+          <p:nvPr/>
+        </p:nvSpPr>
+        <p:spPr>
+          <a:xfrm>
+            <a:off x="4828032" y="3831336"/>
+            <a:ext cx="1645920" cy="292608"/>
+          </a:xfrm>
+          <a:prstGeom prst="rect">
+            <a:avLst/>
+          </a:prstGeom>
+          <a:noFill/>
+        </p:spPr>
+        <p:txBody>
+          <a:bodyPr wrap="square" anchor="t" lIns="0" rIns="0" tIns="0" bIns="0">
+            <a:spAutoFit/>
+          </a:bodyPr>
+          <a:lstStyle/>
+          <a:p>
+            <a:pPr algn="r">
+              <a:lnSpc>
+                <a:spcPct val="118000"/>
+              </a:lnSpc>
+              <a:spcAft>
+                <a:spcPts val="0"/>
+              </a:spcAft>
+            </a:pPr>
+            <a:r>
+              <a:rPr sz="1400" b="1">
+                <a:solidFill>
+                  <a:srgbClr val="F18D83"/>
+                </a:solidFill>
+                <a:latin typeface="IBM Plex Mono"/>
+              </a:rPr>
+              <a:t>3,102 ms</a:t>
+            </a:r>
+          </a:p>
+        </p:txBody>
+      </p:sp>
+      <p:sp>
+        <p:nvSpPr>
+          <p:cNvPr id="12" name="TextBox 11"/>
+          <p:cNvSpPr txBox="1"/>
+          <p:nvPr/>
+        </p:nvSpPr>
+        <p:spPr>
+          <a:xfrm>
+            <a:off x="1005840" y="4261104"/>
+            <a:ext cx="3657600" cy="292608"/>
+          </a:xfrm>
+          <a:prstGeom prst="rect">
+            <a:avLst/>
+          </a:prstGeom>
+          <a:noFill/>
+        </p:spPr>
+        <p:txBody>
+          <a:bodyPr wrap="square" anchor="t" lIns="0" rIns="0" tIns="0" bIns="0">
+            <a:spAutoFit/>
+          </a:bodyPr>
+          <a:lstStyle/>
+          <a:p>
+            <a:pPr algn="l">
+              <a:lnSpc>
+                <a:spcPct val="118000"/>
+              </a:lnSpc>
+              <a:spcAft>
+                <a:spcPts val="0"/>
+              </a:spcAft>
+            </a:pPr>
+            <a:r>
+              <a:rPr sz="1350" b="0">
+                <a:solidFill>
+                  <a:srgbClr val="94A3B2"/>
+                </a:solidFill>
+                <a:latin typeface="IBM Plex Sans"/>
+              </a:rPr>
+              <a:t>Share of the 8,000 ms budget</a:t>
+            </a:r>
+          </a:p>
+        </p:txBody>
+      </p:sp>
+      <p:sp>
+        <p:nvSpPr>
+          <p:cNvPr id="13" name="TextBox 12"/>
+          <p:cNvSpPr txBox="1"/>
+          <p:nvPr/>
+        </p:nvSpPr>
+        <p:spPr>
+          <a:xfrm>
+            <a:off x="4828032" y="4261104"/>
+            <a:ext cx="1645920" cy="292608"/>
+          </a:xfrm>
+          <a:prstGeom prst="rect">
+            <a:avLst/>
+          </a:prstGeom>
+          <a:noFill/>
+        </p:spPr>
+        <p:txBody>
+          <a:bodyPr wrap="square" anchor="t" lIns="0" rIns="0" tIns="0" bIns="0">
+            <a:spAutoFit/>
+          </a:bodyPr>
+          <a:lstStyle/>
+          <a:p>
+            <a:pPr algn="r">
+              <a:lnSpc>
+                <a:spcPct val="118000"/>
+              </a:lnSpc>
+              <a:spcAft>
+                <a:spcPts val="0"/>
+              </a:spcAft>
+            </a:pPr>
+            <a:r>
+              <a:rPr sz="1400" b="1">
+                <a:solidFill>
+                  <a:srgbClr val="F18D83"/>
+                </a:solidFill>
+                <a:latin typeface="IBM Plex Mono"/>
+              </a:rPr>
+              <a:t>39%</a:t>
+            </a:r>
+          </a:p>
+        </p:txBody>
+      </p:sp>
+      <p:sp>
+        <p:nvSpPr>
+          <p:cNvPr id="14" name="TextBox 13"/>
+          <p:cNvSpPr txBox="1"/>
+          <p:nvPr/>
+        </p:nvSpPr>
+        <p:spPr>
+          <a:xfrm>
+            <a:off x="1005840" y="4690872"/>
+            <a:ext cx="3657600" cy="292608"/>
+          </a:xfrm>
+          <a:prstGeom prst="rect">
+            <a:avLst/>
+          </a:prstGeom>
+          <a:noFill/>
+        </p:spPr>
+        <p:txBody>
+          <a:bodyPr wrap="square" anchor="t" lIns="0" rIns="0" tIns="0" bIns="0">
+            <a:spAutoFit/>
+          </a:bodyPr>
+          <a:lstStyle/>
+          <a:p>
+            <a:pPr algn="l">
+              <a:lnSpc>
+                <a:spcPct val="118000"/>
+              </a:lnSpc>
+              <a:spcAft>
+                <a:spcPts val="0"/>
+              </a:spcAft>
+            </a:pPr>
+            <a:r>
+              <a:rPr sz="1350" b="0">
+                <a:solidFill>
+                  <a:srgbClr val="94A3B2"/>
+                </a:solidFill>
+                <a:latin typeface="IBM Plex Sans"/>
+              </a:rPr>
+              <a:t>Decisions changed</a:t>
+            </a:r>
+          </a:p>
+        </p:txBody>
+      </p:sp>
+      <p:sp>
+        <p:nvSpPr>
+          <p:cNvPr id="15" name="TextBox 14"/>
+          <p:cNvSpPr txBox="1"/>
+          <p:nvPr/>
+        </p:nvSpPr>
+        <p:spPr>
+          <a:xfrm>
+            <a:off x="4828032" y="4690872"/>
+            <a:ext cx="1645920" cy="292608"/>
+          </a:xfrm>
+          <a:prstGeom prst="rect">
+            <a:avLst/>
+          </a:prstGeom>
+          <a:noFill/>
+        </p:spPr>
+        <p:txBody>
+          <a:bodyPr wrap="square" anchor="t" lIns="0" rIns="0" tIns="0" bIns="0">
+            <a:spAutoFit/>
+          </a:bodyPr>
+          <a:lstStyle/>
+          <a:p>
+            <a:pPr algn="r">
+              <a:lnSpc>
+                <a:spcPct val="118000"/>
+              </a:lnSpc>
+              <a:spcAft>
+                <a:spcPts val="0"/>
+              </a:spcAft>
+            </a:pPr>
+            <a:r>
+              <a:rPr sz="1400" b="1">
+                <a:solidFill>
+                  <a:srgbClr val="94A3B2"/>
+                </a:solidFill>
+                <a:latin typeface="IBM Plex Mono"/>
+              </a:rPr>
+              <a:t>none</a:t>
+            </a:r>
+          </a:p>
+        </p:txBody>
+      </p:sp>
+      <p:sp>
+        <p:nvSpPr>
+          <p:cNvPr id="16" name="Rectangle 15"/>
           <p:cNvSpPr/>
           <p:nvPr/>
         </p:nvSpPr>
         <p:spPr>
           <a:xfrm>
-            <a:off x="4521708" y="4315968"/>
-            <a:ext cx="640080" cy="20320"/>
+            <a:off x="7187184" y="2798064"/>
+            <a:ext cx="4297680" cy="2377440"/>
           </a:xfrm>
           <a:prstGeom prst="rect">
             <a:avLst/>
           </a:prstGeom>
           <a:solidFill>
-            <a:srgbClr val="74ABF0"/>
+            <a:srgbClr val="151D25"/>
           </a:solidFill>
-          <a:ln>
-            <a:noFill/>
+          <a:ln w="9525">
+            <a:solidFill>
+              <a:srgbClr val="74ABF0"/>
+            </a:solidFill>
           </a:ln>
           <a:effectLst/>
         </p:spPr>
@@ -12519,29 +13627,71 @@
       </p:sp>
       <p:sp>
         <p:nvSpPr>
-          <p:cNvPr id="12" name="TextBox 11"/>
-          <p:cNvSpPr txBox="1"/>
-          <p:nvPr/>
-        </p:nvSpPr>
-        <p:spPr>
-          <a:xfrm>
-            <a:off x="3538728" y="4517136"/>
-            <a:ext cx="2606040" cy="1554480"/>
-          </a:xfrm>
-          <a:prstGeom prst="rect">
-            <a:avLst/>
-          </a:prstGeom>
-          <a:noFill/>
-        </p:spPr>
-        <p:txBody>
-          <a:bodyPr wrap="square" anchor="t" lIns="0" rIns="0" tIns="0" bIns="0">
-            <a:spAutoFit/>
-          </a:bodyPr>
-          <a:lstStyle/>
-          <a:p>
-            <a:pPr algn="ctr">
-              <a:lnSpc>
-                <a:spcPct val="134000"/>
+          <p:cNvPr id="17" name="TextBox 16"/>
+          <p:cNvSpPr txBox="1"/>
+          <p:nvPr/>
+        </p:nvSpPr>
+        <p:spPr>
+          <a:xfrm>
+            <a:off x="7479792" y="3017520"/>
+            <a:ext cx="3749039" cy="274320"/>
+          </a:xfrm>
+          <a:prstGeom prst="rect">
+            <a:avLst/>
+          </a:prstGeom>
+          <a:noFill/>
+        </p:spPr>
+        <p:txBody>
+          <a:bodyPr wrap="square" anchor="t" lIns="0" rIns="0" tIns="0" bIns="0">
+            <a:spAutoFit/>
+          </a:bodyPr>
+          <a:lstStyle/>
+          <a:p>
+            <a:pPr algn="l">
+              <a:lnSpc>
+                <a:spcPct val="118000"/>
+              </a:lnSpc>
+              <a:spcAft>
+                <a:spcPts val="0"/>
+              </a:spcAft>
+            </a:pPr>
+            <a:r>
+              <a:rPr sz="950" b="0" spc="120">
+                <a:solidFill>
+                  <a:srgbClr val="74ABF0"/>
+                </a:solidFill>
+                <a:latin typeface="IBM Plex Mono"/>
+              </a:rPr>
+              <a:t>WHY IT IS OFF</a:t>
+            </a:r>
+          </a:p>
+        </p:txBody>
+      </p:sp>
+      <p:sp>
+        <p:nvSpPr>
+          <p:cNvPr id="18" name="TextBox 17"/>
+          <p:cNvSpPr txBox="1"/>
+          <p:nvPr/>
+        </p:nvSpPr>
+        <p:spPr>
+          <a:xfrm>
+            <a:off x="7479792" y="3401568"/>
+            <a:ext cx="3749039" cy="1554480"/>
+          </a:xfrm>
+          <a:prstGeom prst="rect">
+            <a:avLst/>
+          </a:prstGeom>
+          <a:noFill/>
+        </p:spPr>
+        <p:txBody>
+          <a:bodyPr wrap="square" anchor="t" lIns="0" rIns="0" tIns="0" bIns="0">
+            <a:spAutoFit/>
+          </a:bodyPr>
+          <a:lstStyle/>
+          <a:p>
+            <a:pPr algn="l">
+              <a:lnSpc>
+                <a:spcPct val="130000"/>
               </a:lnSpc>
               <a:spcAft>
                 <a:spcPts val="0"/>
@@ -12554,318 +13704,132 @@
                 </a:solidFill>
                 <a:latin typeface="IBM Plex Sans"/>
               </a:rPr>
-              <a:t>Offline replay harness over the synthetic datasets, the live sandbox API client, and latency benchmarking to stay well under platform thresholds.</a:t>
-            </a:r>
-          </a:p>
-        </p:txBody>
-      </p:sp>
-      <p:pic>
-        <p:nvPicPr>
-          <p:cNvPr id="13" name="Picture 12" descr="simon.png"/>
-          <p:cNvPicPr>
-            <a:picLocks noChangeAspect="1"/>
-          </p:cNvPicPr>
-          <p:nvPr/>
-        </p:nvPicPr>
-        <p:blipFill>
-          <a:blip r:embed="rId4"/>
-          <a:stretch>
-            <a:fillRect/>
-          </a:stretch>
-        </p:blipFill>
-        <p:spPr>
-          <a:xfrm>
-            <a:off x="6880860" y="2084831"/>
-            <a:ext cx="1572768" cy="1572768"/>
-          </a:xfrm>
-          <a:prstGeom prst="rect">
-            <a:avLst/>
-          </a:prstGeom>
-        </p:spPr>
-      </p:pic>
-      <p:sp>
-        <p:nvSpPr>
-          <p:cNvPr id="14" name="TextBox 13"/>
-          <p:cNvSpPr txBox="1"/>
-          <p:nvPr/>
-        </p:nvSpPr>
-        <p:spPr>
-          <a:xfrm>
-            <a:off x="6364224" y="3858768"/>
-            <a:ext cx="2606040" cy="365760"/>
-          </a:xfrm>
-          <a:prstGeom prst="rect">
-            <a:avLst/>
-          </a:prstGeom>
-          <a:noFill/>
-        </p:spPr>
-        <p:txBody>
-          <a:bodyPr wrap="square" anchor="t" lIns="0" rIns="0" tIns="0" bIns="0">
-            <a:spAutoFit/>
-          </a:bodyPr>
-          <a:lstStyle/>
-          <a:p>
-            <a:pPr algn="ctr">
-              <a:lnSpc>
-                <a:spcPct val="118000"/>
-              </a:lnSpc>
-              <a:spcAft>
-                <a:spcPts val="0"/>
-              </a:spcAft>
-            </a:pPr>
-            <a:r>
-              <a:rPr sz="1600" b="1">
+              <a:t>A 3,200× latency increase for identical outcomes.</a:t>
+            </a:r>
+          </a:p>
+          <a:p>
+            <a:pPr algn="l">
+              <a:lnSpc>
+                <a:spcPct val="130000"/>
+              </a:lnSpc>
+              <a:spcAft>
+                <a:spcPts val="0"/>
+              </a:spcAft>
+            </a:pPr>
+            <a:r>
+              <a:rPr sz="1150" b="0">
+                <a:solidFill>
+                  <a:srgbClr val="94A3B2"/>
+                </a:solidFill>
+                <a:latin typeface="IBM Plex Sans"/>
+              </a:rPr>
+              <a:t/>
+            </a:r>
+          </a:p>
+          <a:p>
+            <a:pPr algn="l">
+              <a:lnSpc>
+                <a:spcPct val="130000"/>
+              </a:lnSpc>
+              <a:spcAft>
+                <a:spcPts val="0"/>
+              </a:spcAft>
+            </a:pPr>
+            <a:r>
+              <a:rPr sz="1150" b="0">
+                <a:solidFill>
+                  <a:srgbClr val="94A3B2"/>
+                </a:solidFill>
+                <a:latin typeface="IBM Plex Sans"/>
+              </a:rPr>
+              <a:t>The advisor answers one question, never sees the policy, and can only raise doubt — never grant permission.</a:t>
+            </a:r>
+          </a:p>
+          <a:p>
+            <a:pPr algn="l">
+              <a:lnSpc>
+                <a:spcPct val="130000"/>
+              </a:lnSpc>
+              <a:spcAft>
+                <a:spcPts val="0"/>
+              </a:spcAft>
+            </a:pPr>
+            <a:r>
+              <a:rPr sz="1150" b="0">
+                <a:solidFill>
+                  <a:srgbClr val="94A3B2"/>
+                </a:solidFill>
+                <a:latin typeface="IBM Plex Sans"/>
+              </a:rPr>
+              <a:t/>
+            </a:r>
+          </a:p>
+          <a:p>
+            <a:pPr algn="l">
+              <a:lnSpc>
+                <a:spcPct val="130000"/>
+              </a:lnSpc>
+              <a:spcAft>
+                <a:spcPts val="0"/>
+              </a:spcAft>
+            </a:pPr>
+            <a:r>
+              <a:rPr sz="1150" b="0">
+                <a:solidFill>
+                  <a:srgbClr val="94A3B2"/>
+                </a:solidFill>
+                <a:latin typeface="IBM Plex Sans"/>
+              </a:rPr>
+              <a:t>A broken model gives the same decisions as no model.</a:t>
+            </a:r>
+          </a:p>
+        </p:txBody>
+      </p:sp>
+      <p:sp>
+        <p:nvSpPr>
+          <p:cNvPr id="19" name="TextBox 18"/>
+          <p:cNvSpPr txBox="1"/>
+          <p:nvPr/>
+        </p:nvSpPr>
+        <p:spPr>
+          <a:xfrm>
+            <a:off x="713232" y="5468112"/>
+            <a:ext cx="10607040" cy="548640"/>
+          </a:xfrm>
+          <a:prstGeom prst="rect">
+            <a:avLst/>
+          </a:prstGeom>
+          <a:noFill/>
+        </p:spPr>
+        <p:txBody>
+          <a:bodyPr wrap="square" anchor="t" lIns="0" rIns="0" tIns="0" bIns="0">
+            <a:spAutoFit/>
+          </a:bodyPr>
+          <a:lstStyle/>
+          <a:p>
+            <a:pPr algn="l">
+              <a:lnSpc>
+                <a:spcPct val="130000"/>
+              </a:lnSpc>
+              <a:spcAft>
+                <a:spcPts val="0"/>
+              </a:spcAft>
+            </a:pPr>
+            <a:r>
+              <a:rPr sz="1400" b="0">
                 <a:solidFill>
                   <a:srgbClr val="EDF2F7"/>
                 </a:solidFill>
                 <a:latin typeface="IBM Plex Sans"/>
               </a:rPr>
-              <a:t>Simon Markiewicz</a:t>
-            </a:r>
-          </a:p>
-        </p:txBody>
-      </p:sp>
-      <p:sp>
-        <p:nvSpPr>
-          <p:cNvPr id="15" name="Rectangle 14"/>
-          <p:cNvSpPr/>
-          <p:nvPr/>
-        </p:nvSpPr>
-        <p:spPr>
-          <a:xfrm>
-            <a:off x="7347204" y="4315968"/>
-            <a:ext cx="640080" cy="20320"/>
-          </a:xfrm>
-          <a:prstGeom prst="rect">
-            <a:avLst/>
-          </a:prstGeom>
-          <a:solidFill>
-            <a:srgbClr val="74ABF0"/>
-          </a:solidFill>
-          <a:ln>
-            <a:noFill/>
-          </a:ln>
-          <a:effectLst/>
-        </p:spPr>
-        <p:style>
-          <a:lnRef idx="1">
-            <a:schemeClr val="accent1"/>
-          </a:lnRef>
-          <a:fillRef idx="3">
-            <a:schemeClr val="accent1"/>
-          </a:fillRef>
-          <a:effectRef idx="2">
-            <a:schemeClr val="accent1"/>
-          </a:effectRef>
-          <a:fontRef idx="minor">
-            <a:schemeClr val="lt1"/>
-          </a:fontRef>
-        </p:style>
-        <p:txBody>
-          <a:bodyPr rtlCol="0" anchor="ctr"/>
-          <a:lstStyle/>
-          <a:p>
-            <a:pPr algn="ctr"/>
-          </a:p>
-        </p:txBody>
-      </p:sp>
-      <p:sp>
-        <p:nvSpPr>
-          <p:cNvPr id="16" name="TextBox 15"/>
-          <p:cNvSpPr txBox="1"/>
-          <p:nvPr/>
-        </p:nvSpPr>
-        <p:spPr>
-          <a:xfrm>
-            <a:off x="6364224" y="4517136"/>
-            <a:ext cx="2606040" cy="1554480"/>
-          </a:xfrm>
-          <a:prstGeom prst="rect">
-            <a:avLst/>
-          </a:prstGeom>
-          <a:noFill/>
-        </p:spPr>
-        <p:txBody>
-          <a:bodyPr wrap="square" anchor="t" lIns="0" rIns="0" tIns="0" bIns="0">
-            <a:spAutoFit/>
-          </a:bodyPr>
-          <a:lstStyle/>
-          <a:p>
-            <a:pPr algn="ctr">
-              <a:lnSpc>
-                <a:spcPct val="134000"/>
-              </a:lnSpc>
-              <a:spcAft>
-                <a:spcPts val="0"/>
-              </a:spcAft>
-            </a:pPr>
-            <a:r>
-              <a:rPr sz="1150" b="0">
-                <a:solidFill>
-                  <a:srgbClr val="94A3B2"/>
-                </a:solidFill>
-                <a:latin typeface="IBM Plex Sans"/>
-              </a:rPr>
-              <a:t>Spend mandate policies and merchant trust validation, partner alignment with mentors, and the presentation flow across the core demo scenarios.</a:t>
-            </a:r>
-          </a:p>
-        </p:txBody>
-      </p:sp>
-      <p:pic>
-        <p:nvPicPr>
-          <p:cNvPr id="17" name="Picture 16" descr="tacdin.png"/>
-          <p:cNvPicPr>
-            <a:picLocks noChangeAspect="1"/>
-          </p:cNvPicPr>
-          <p:nvPr/>
-        </p:nvPicPr>
-        <p:blipFill>
-          <a:blip r:embed="rId5"/>
-          <a:stretch>
-            <a:fillRect/>
-          </a:stretch>
-        </p:blipFill>
-        <p:spPr>
-          <a:xfrm>
-            <a:off x="9706356" y="2084831"/>
-            <a:ext cx="1572768" cy="1572768"/>
-          </a:xfrm>
-          <a:prstGeom prst="rect">
-            <a:avLst/>
-          </a:prstGeom>
-        </p:spPr>
-      </p:pic>
-      <p:sp>
-        <p:nvSpPr>
-          <p:cNvPr id="18" name="TextBox 17"/>
-          <p:cNvSpPr txBox="1"/>
-          <p:nvPr/>
-        </p:nvSpPr>
-        <p:spPr>
-          <a:xfrm>
-            <a:off x="9189720" y="3858768"/>
-            <a:ext cx="2606040" cy="365760"/>
-          </a:xfrm>
-          <a:prstGeom prst="rect">
-            <a:avLst/>
-          </a:prstGeom>
-          <a:noFill/>
-        </p:spPr>
-        <p:txBody>
-          <a:bodyPr wrap="square" anchor="t" lIns="0" rIns="0" tIns="0" bIns="0">
-            <a:spAutoFit/>
-          </a:bodyPr>
-          <a:lstStyle/>
-          <a:p>
-            <a:pPr algn="ctr">
-              <a:lnSpc>
-                <a:spcPct val="118000"/>
-              </a:lnSpc>
-              <a:spcAft>
-                <a:spcPts val="0"/>
-              </a:spcAft>
-            </a:pPr>
-            <a:r>
-              <a:rPr sz="1600" b="1">
-                <a:solidFill>
-                  <a:srgbClr val="EDF2F7"/>
-                </a:solidFill>
-                <a:latin typeface="IBM Plex Sans"/>
-              </a:rPr>
-              <a:t>Tacdin Ozmen</a:t>
-            </a:r>
-          </a:p>
-        </p:txBody>
-      </p:sp>
-      <p:sp>
-        <p:nvSpPr>
-          <p:cNvPr id="19" name="Rectangle 18"/>
-          <p:cNvSpPr/>
-          <p:nvPr/>
-        </p:nvSpPr>
-        <p:spPr>
-          <a:xfrm>
-            <a:off x="10172700" y="4315968"/>
-            <a:ext cx="640080" cy="20320"/>
-          </a:xfrm>
-          <a:prstGeom prst="rect">
-            <a:avLst/>
-          </a:prstGeom>
-          <a:solidFill>
-            <a:srgbClr val="74ABF0"/>
-          </a:solidFill>
-          <a:ln>
-            <a:noFill/>
-          </a:ln>
-          <a:effectLst/>
-        </p:spPr>
-        <p:style>
-          <a:lnRef idx="1">
-            <a:schemeClr val="accent1"/>
-          </a:lnRef>
-          <a:fillRef idx="3">
-            <a:schemeClr val="accent1"/>
-          </a:fillRef>
-          <a:effectRef idx="2">
-            <a:schemeClr val="accent1"/>
-          </a:effectRef>
-          <a:fontRef idx="minor">
-            <a:schemeClr val="lt1"/>
-          </a:fontRef>
-        </p:style>
-        <p:txBody>
-          <a:bodyPr rtlCol="0" anchor="ctr"/>
-          <a:lstStyle/>
-          <a:p>
-            <a:pPr algn="ctr"/>
+              <a:t>The AI here is the thing being controlled, not the thing doing the controlling. Putting a model in the path that gates spending would be the vulnerability.</a:t>
+            </a:r>
           </a:p>
         </p:txBody>
       </p:sp>
       <p:sp>
         <p:nvSpPr>
           <p:cNvPr id="20" name="TextBox 19"/>
-          <p:cNvSpPr txBox="1"/>
-          <p:nvPr/>
-        </p:nvSpPr>
-        <p:spPr>
-          <a:xfrm>
-            <a:off x="9189720" y="4517136"/>
-            <a:ext cx="2606040" cy="1554480"/>
-          </a:xfrm>
-          <a:prstGeom prst="rect">
-            <a:avLst/>
-          </a:prstGeom>
-          <a:noFill/>
-        </p:spPr>
-        <p:txBody>
-          <a:bodyPr wrap="square" anchor="t" lIns="0" rIns="0" tIns="0" bIns="0">
-            <a:spAutoFit/>
-          </a:bodyPr>
-          <a:lstStyle/>
-          <a:p>
-            <a:pPr algn="ctr">
-              <a:lnSpc>
-                <a:spcPct val="134000"/>
-              </a:lnSpc>
-              <a:spcAft>
-                <a:spcPts val="0"/>
-              </a:spcAft>
-            </a:pPr>
-            <a:r>
-              <a:rPr sz="1150" b="0">
-                <a:solidFill>
-                  <a:srgbClr val="94A3B2"/>
-                </a:solidFill>
-                <a:latin typeface="IBM Plex Sans"/>
-              </a:rPr>
-              <a:t>The core deterministic decision engine, evidence logs for approve, decline and step-up outcomes, and the link to the decoupled user interface.</a:t>
-            </a:r>
-          </a:p>
-        </p:txBody>
-      </p:sp>
-      <p:sp>
-        <p:nvSpPr>
-          <p:cNvPr id="21" name="TextBox 20"/>
           <p:cNvSpPr txBox="1"/>
           <p:nvPr/>
         </p:nvSpPr>
@@ -12907,7 +13871,7 @@
       </p:sp>
       <p:sp>
         <p:nvSpPr>
-          <p:cNvPr id="22" name="TextBox 21"/>
+          <p:cNvPr id="21" name="TextBox 20"/>
           <p:cNvSpPr txBox="1"/>
           <p:nvPr/>
         </p:nvSpPr>

</xml_diff>